<commit_message>
docs(deck): S2 → four-generation panel (2018 · v8b · 2023 · distilled), SV+EN
Replace the two-frame example with the four-panel comparison — individual
frames with language-correct captions per deck (SV/EN) instead of baked-in
text, same tile/extent/palette across all four.

Verified-by: soffice render of S2 in both decks — 4 panels, captions, legend correct
Co-Authored-By: Claude Fable 5 <noreply@anthropic.com>
</commit_message>
<xml_diff>
--- a/docs/decks/v8b_nmd_benchmark_DES.pptx
+++ b/docs/decks/v8b_nmd_benchmark_DES.pptx
@@ -2499,7 +2499,7 @@
                 <a:ea typeface="Space Grotesk" pitchFamily="34" charset="-122"/>
                 <a:cs typeface="Space Grotesk" pitchFamily="34" charset="-120"/>
               </a:rPr>
-              <a:t>Exempel — NMD2023 vs modellen</a:t>
+              <a:t>Fyra generationer — samma landskap</a:t>
             </a:r>
             <a:endParaRPr lang="en-US" sz="3200" dirty="0"/>
           </a:p>
@@ -2514,7 +2514,7 @@
         <p:spPr>
           <a:xfrm>
             <a:off x="658368" y="1133856"/>
-            <a:ext cx="10972800" cy="365760"/>
+            <a:ext cx="11155680" cy="365760"/>
           </a:xfrm>
           <a:prstGeom prst="rect">
             <a:avLst/>
@@ -2530,7 +2530,7 @@
               <a:buNone/>
             </a:pPr>
             <a:r>
-              <a:rPr lang="en-US" sz="1350" dirty="0">
+              <a:rPr lang="en-US" sz="1300" dirty="0">
                 <a:solidFill>
                   <a:srgbClr val="9DBDB0"/>
                 </a:solidFill>
@@ -2538,9 +2538,9 @@
                 <a:ea typeface="Space Grotesk" pitchFamily="34" charset="-122"/>
                 <a:cs typeface="Space Grotesk" pitchFamily="34" charset="-120"/>
               </a:rPr>
-              <a:t>En 5×5 km-tile, unified färgpalett (tile_331280_6541280). Vänster: NMD2023-baserad etikett. Höger: distillerad modell.</a:t>
-            </a:r>
-            <a:endParaRPr lang="en-US" sz="1350" dirty="0"/>
+              <a:t>En 5×5 km-tile, identisk extent och unified färgpalett (tile_331280_6541280): etikettkällorna 2018/2023 och modellerna tränade mot respektive mål.</a:t>
+            </a:r>
+            <a:endParaRPr lang="en-US" sz="1300" dirty="0"/>
           </a:p>
         </p:txBody>
       </p:sp>
@@ -2560,17 +2560,56 @@
         </p:blipFill>
         <p:spPr>
           <a:xfrm>
-            <a:off x="1737360" y="1737360"/>
-            <a:ext cx="3520440" cy="3520440"/>
+            <a:off x="493776" y="1783080"/>
+            <a:ext cx="2697480" cy="2697480"/>
           </a:xfrm>
           <a:prstGeom prst="rect">
             <a:avLst/>
           </a:prstGeom>
         </p:spPr>
       </p:pic>
+      <p:sp>
+        <p:nvSpPr>
+          <p:cNvPr id="6" name="Text 3"/>
+          <p:cNvSpPr/>
+          <p:nvPr/>
+        </p:nvSpPr>
+        <p:spPr>
+          <a:xfrm>
+            <a:off x="448056" y="4535424"/>
+            <a:ext cx="2788920" cy="320040"/>
+          </a:xfrm>
+          <a:prstGeom prst="rect">
+            <a:avLst/>
+          </a:prstGeom>
+          <a:noFill/>
+          <a:ln/>
+        </p:spPr>
+        <p:txBody>
+          <a:bodyPr wrap="square" lIns="0" tIns="0" rIns="0" bIns="0" rtlCol="0" anchor="ctr"/>
+          <a:lstStyle/>
+          <a:p>
+            <a:pPr algn="ctr" indent="0" marL="0">
+              <a:buNone/>
+            </a:pPr>
+            <a:r>
+              <a:rPr lang="en-US" sz="1250" b="1" dirty="0">
+                <a:solidFill>
+                  <a:srgbClr val="9DBDB0"/>
+                </a:solidFill>
+                <a:latin typeface="Space Grotesk" pitchFamily="34" charset="0"/>
+                <a:ea typeface="Space Grotesk" pitchFamily="34" charset="-122"/>
+                <a:cs typeface="Space Grotesk" pitchFamily="34" charset="-120"/>
+              </a:rPr>
+              <a:t>NMD2018-etikett</a:t>
+            </a:r>
+            <a:endParaRPr lang="en-US" sz="1250" dirty="0"/>
+          </a:p>
+        </p:txBody>
+      </p:sp>
       <p:pic>
         <p:nvPicPr>
-          <p:cNvPr id="6" name="Image 1" descr="preencoded.png">    </p:cNvPr>
+          <p:cNvPr id="7" name="Image 1" descr="preencoded.png">    </p:cNvPr>
           <p:cNvPicPr>
             <a:picLocks noChangeAspect="1"/>
           </p:cNvPicPr>
@@ -2584,8 +2623,8 @@
         </p:blipFill>
         <p:spPr>
           <a:xfrm>
-            <a:off x="6995160" y="1737360"/>
-            <a:ext cx="3520440" cy="3520440"/>
+            <a:off x="3328416" y="1783080"/>
+            <a:ext cx="2697480" cy="2697480"/>
           </a:xfrm>
           <a:prstGeom prst="rect">
             <a:avLst/>
@@ -2594,14 +2633,14 @@
       </p:pic>
       <p:sp>
         <p:nvSpPr>
-          <p:cNvPr id="7" name="Text 3"/>
-          <p:cNvSpPr/>
-          <p:nvPr/>
-        </p:nvSpPr>
-        <p:spPr>
-          <a:xfrm>
-            <a:off x="1737360" y="5330952"/>
-            <a:ext cx="3520440" cy="365760"/>
+          <p:cNvPr id="8" name="Text 4"/>
+          <p:cNvSpPr/>
+          <p:nvPr/>
+        </p:nvSpPr>
+        <p:spPr>
+          <a:xfrm>
+            <a:off x="3282696" y="4535424"/>
+            <a:ext cx="2788920" cy="320040"/>
           </a:xfrm>
           <a:prstGeom prst="rect">
             <a:avLst/>
@@ -2617,7 +2656,70 @@
               <a:buNone/>
             </a:pPr>
             <a:r>
-              <a:rPr lang="en-US" sz="1500" b="1" dirty="0">
+              <a:rPr lang="en-US" sz="1250" b="1" dirty="0">
+                <a:solidFill>
+                  <a:srgbClr val="FFFFFF"/>
+                </a:solidFill>
+                <a:latin typeface="Space Grotesk" pitchFamily="34" charset="0"/>
+                <a:ea typeface="Space Grotesk" pitchFamily="34" charset="-122"/>
+                <a:cs typeface="Space Grotesk" pitchFamily="34" charset="-120"/>
+              </a:rPr>
+              <a:t>v8b (tränad på 2018)</a:t>
+            </a:r>
+            <a:endParaRPr lang="en-US" sz="1250" dirty="0"/>
+          </a:p>
+        </p:txBody>
+      </p:sp>
+      <p:pic>
+        <p:nvPicPr>
+          <p:cNvPr id="9" name="Image 2" descr="preencoded.png">    </p:cNvPr>
+          <p:cNvPicPr>
+            <a:picLocks noChangeAspect="1"/>
+          </p:cNvPicPr>
+          <p:nvPr/>
+        </p:nvPicPr>
+        <p:blipFill>
+          <a:blip r:embed="rId3"/>
+          <a:stretch>
+            <a:fillRect/>
+          </a:stretch>
+        </p:blipFill>
+        <p:spPr>
+          <a:xfrm>
+            <a:off x="6163056" y="1783080"/>
+            <a:ext cx="2697480" cy="2697480"/>
+          </a:xfrm>
+          <a:prstGeom prst="rect">
+            <a:avLst/>
+          </a:prstGeom>
+        </p:spPr>
+      </p:pic>
+      <p:sp>
+        <p:nvSpPr>
+          <p:cNvPr id="10" name="Text 5"/>
+          <p:cNvSpPr/>
+          <p:nvPr/>
+        </p:nvSpPr>
+        <p:spPr>
+          <a:xfrm>
+            <a:off x="6117336" y="4535424"/>
+            <a:ext cx="2788920" cy="320040"/>
+          </a:xfrm>
+          <a:prstGeom prst="rect">
+            <a:avLst/>
+          </a:prstGeom>
+          <a:noFill/>
+          <a:ln/>
+        </p:spPr>
+        <p:txBody>
+          <a:bodyPr wrap="square" lIns="0" tIns="0" rIns="0" bIns="0" rtlCol="0" anchor="ctr"/>
+          <a:lstStyle/>
+          <a:p>
+            <a:pPr algn="ctr" indent="0" marL="0">
+              <a:buNone/>
+            </a:pPr>
+            <a:r>
+              <a:rPr lang="en-US" sz="1250" b="1" dirty="0">
                 <a:solidFill>
                   <a:srgbClr val="CDFCE3"/>
                 </a:solidFill>
@@ -2627,20 +2729,44 @@
               </a:rPr>
               <a:t>NMD2023-etikett</a:t>
             </a:r>
-            <a:endParaRPr lang="en-US" sz="1500" dirty="0"/>
-          </a:p>
-        </p:txBody>
-      </p:sp>
-      <p:sp>
-        <p:nvSpPr>
-          <p:cNvPr id="8" name="Text 4"/>
-          <p:cNvSpPr/>
-          <p:nvPr/>
-        </p:nvSpPr>
-        <p:spPr>
-          <a:xfrm>
-            <a:off x="6995160" y="5330952"/>
-            <a:ext cx="3520440" cy="365760"/>
+            <a:endParaRPr lang="en-US" sz="1250" dirty="0"/>
+          </a:p>
+        </p:txBody>
+      </p:sp>
+      <p:pic>
+        <p:nvPicPr>
+          <p:cNvPr id="11" name="Image 3" descr="preencoded.png">    </p:cNvPr>
+          <p:cNvPicPr>
+            <a:picLocks noChangeAspect="1"/>
+          </p:cNvPicPr>
+          <p:nvPr/>
+        </p:nvPicPr>
+        <p:blipFill>
+          <a:blip r:embed="rId4"/>
+          <a:stretch>
+            <a:fillRect/>
+          </a:stretch>
+        </p:blipFill>
+        <p:spPr>
+          <a:xfrm>
+            <a:off x="8997696" y="1783080"/>
+            <a:ext cx="2697480" cy="2697480"/>
+          </a:xfrm>
+          <a:prstGeom prst="rect">
+            <a:avLst/>
+          </a:prstGeom>
+        </p:spPr>
+      </p:pic>
+      <p:sp>
+        <p:nvSpPr>
+          <p:cNvPr id="12" name="Text 6"/>
+          <p:cNvSpPr/>
+          <p:nvPr/>
+        </p:nvSpPr>
+        <p:spPr>
+          <a:xfrm>
+            <a:off x="8951976" y="4535424"/>
+            <a:ext cx="2788920" cy="320040"/>
           </a:xfrm>
           <a:prstGeom prst="rect">
             <a:avLst/>
@@ -2656,7 +2782,7 @@
               <a:buNone/>
             </a:pPr>
             <a:r>
-              <a:rPr lang="en-US" sz="1500" b="1" dirty="0">
+              <a:rPr lang="en-US" sz="1250" b="1" dirty="0">
                 <a:solidFill>
                   <a:srgbClr val="FF826C"/>
                 </a:solidFill>
@@ -2666,19 +2792,19 @@
               </a:rPr>
               <a:t>v8b-NFI (distillerad)</a:t>
             </a:r>
-            <a:endParaRPr lang="en-US" sz="1500" dirty="0"/>
-          </a:p>
-        </p:txBody>
-      </p:sp>
-      <p:sp>
-        <p:nvSpPr>
-          <p:cNvPr id="9" name="Shape 5"/>
-          <p:cNvSpPr/>
-          <p:nvPr/>
-        </p:nvSpPr>
-        <p:spPr>
-          <a:xfrm>
-            <a:off x="685800" y="6007608"/>
+            <a:endParaRPr lang="en-US" sz="1250" dirty="0"/>
+          </a:p>
+        </p:txBody>
+      </p:sp>
+      <p:sp>
+        <p:nvSpPr>
+          <p:cNvPr id="13" name="Shape 7"/>
+          <p:cNvSpPr/>
+          <p:nvPr/>
+        </p:nvSpPr>
+        <p:spPr>
+          <a:xfrm>
+            <a:off x="685800" y="5276088"/>
             <a:ext cx="182880" cy="182880"/>
           </a:xfrm>
           <a:prstGeom prst="rect">
@@ -2692,13 +2818,13 @@
       </p:sp>
       <p:sp>
         <p:nvSpPr>
-          <p:cNvPr id="10" name="Text 6"/>
-          <p:cNvSpPr/>
-          <p:nvPr/>
-        </p:nvSpPr>
-        <p:spPr>
-          <a:xfrm>
-            <a:off x="960120" y="5961888"/>
+          <p:cNvPr id="14" name="Text 8"/>
+          <p:cNvSpPr/>
+          <p:nvPr/>
+        </p:nvSpPr>
+        <p:spPr>
+          <a:xfrm>
+            <a:off x="960120" y="5230368"/>
             <a:ext cx="2286000" cy="274320"/>
           </a:xfrm>
           <a:prstGeom prst="rect">
@@ -2731,13 +2857,13 @@
       </p:sp>
       <p:sp>
         <p:nvSpPr>
-          <p:cNvPr id="11" name="Shape 7"/>
-          <p:cNvSpPr/>
-          <p:nvPr/>
-        </p:nvSpPr>
-        <p:spPr>
-          <a:xfrm>
-            <a:off x="3429000" y="6007608"/>
+          <p:cNvPr id="15" name="Shape 9"/>
+          <p:cNvSpPr/>
+          <p:nvPr/>
+        </p:nvSpPr>
+        <p:spPr>
+          <a:xfrm>
+            <a:off x="3429000" y="5276088"/>
             <a:ext cx="182880" cy="182880"/>
           </a:xfrm>
           <a:prstGeom prst="rect">
@@ -2751,13 +2877,13 @@
       </p:sp>
       <p:sp>
         <p:nvSpPr>
-          <p:cNvPr id="12" name="Text 8"/>
-          <p:cNvSpPr/>
-          <p:nvPr/>
-        </p:nvSpPr>
-        <p:spPr>
-          <a:xfrm>
-            <a:off x="3703320" y="5961888"/>
+          <p:cNvPr id="16" name="Text 10"/>
+          <p:cNvSpPr/>
+          <p:nvPr/>
+        </p:nvSpPr>
+        <p:spPr>
+          <a:xfrm>
+            <a:off x="3703320" y="5230368"/>
             <a:ext cx="2286000" cy="274320"/>
           </a:xfrm>
           <a:prstGeom prst="rect">
@@ -2790,13 +2916,13 @@
       </p:sp>
       <p:sp>
         <p:nvSpPr>
-          <p:cNvPr id="13" name="Shape 9"/>
-          <p:cNvSpPr/>
-          <p:nvPr/>
-        </p:nvSpPr>
-        <p:spPr>
-          <a:xfrm>
-            <a:off x="6172200" y="6007608"/>
+          <p:cNvPr id="17" name="Shape 11"/>
+          <p:cNvSpPr/>
+          <p:nvPr/>
+        </p:nvSpPr>
+        <p:spPr>
+          <a:xfrm>
+            <a:off x="6172200" y="5276088"/>
             <a:ext cx="182880" cy="182880"/>
           </a:xfrm>
           <a:prstGeom prst="rect">
@@ -2810,13 +2936,13 @@
       </p:sp>
       <p:sp>
         <p:nvSpPr>
-          <p:cNvPr id="14" name="Text 10"/>
-          <p:cNvSpPr/>
-          <p:nvPr/>
-        </p:nvSpPr>
-        <p:spPr>
-          <a:xfrm>
-            <a:off x="6446520" y="5961888"/>
+          <p:cNvPr id="18" name="Text 12"/>
+          <p:cNvSpPr/>
+          <p:nvPr/>
+        </p:nvSpPr>
+        <p:spPr>
+          <a:xfrm>
+            <a:off x="6446520" y="5230368"/>
             <a:ext cx="2286000" cy="274320"/>
           </a:xfrm>
           <a:prstGeom prst="rect">
@@ -2849,13 +2975,13 @@
       </p:sp>
       <p:sp>
         <p:nvSpPr>
-          <p:cNvPr id="15" name="Shape 11"/>
-          <p:cNvSpPr/>
-          <p:nvPr/>
-        </p:nvSpPr>
-        <p:spPr>
-          <a:xfrm>
-            <a:off x="8915400" y="6007608"/>
+          <p:cNvPr id="19" name="Shape 13"/>
+          <p:cNvSpPr/>
+          <p:nvPr/>
+        </p:nvSpPr>
+        <p:spPr>
+          <a:xfrm>
+            <a:off x="8915400" y="5276088"/>
             <a:ext cx="182880" cy="182880"/>
           </a:xfrm>
           <a:prstGeom prst="rect">
@@ -2869,13 +2995,13 @@
       </p:sp>
       <p:sp>
         <p:nvSpPr>
-          <p:cNvPr id="16" name="Text 12"/>
-          <p:cNvSpPr/>
-          <p:nvPr/>
-        </p:nvSpPr>
-        <p:spPr>
-          <a:xfrm>
-            <a:off x="9189720" y="5961888"/>
+          <p:cNvPr id="20" name="Text 14"/>
+          <p:cNvSpPr/>
+          <p:nvPr/>
+        </p:nvSpPr>
+        <p:spPr>
+          <a:xfrm>
+            <a:off x="9189720" y="5230368"/>
             <a:ext cx="2286000" cy="274320"/>
           </a:xfrm>
           <a:prstGeom prst="rect">
@@ -2908,13 +3034,13 @@
       </p:sp>
       <p:sp>
         <p:nvSpPr>
-          <p:cNvPr id="17" name="Shape 13"/>
-          <p:cNvSpPr/>
-          <p:nvPr/>
-        </p:nvSpPr>
-        <p:spPr>
-          <a:xfrm>
-            <a:off x="685800" y="6300216"/>
+          <p:cNvPr id="21" name="Shape 15"/>
+          <p:cNvSpPr/>
+          <p:nvPr/>
+        </p:nvSpPr>
+        <p:spPr>
+          <a:xfrm>
+            <a:off x="685800" y="5568696"/>
             <a:ext cx="182880" cy="182880"/>
           </a:xfrm>
           <a:prstGeom prst="rect">
@@ -2928,13 +3054,13 @@
       </p:sp>
       <p:sp>
         <p:nvSpPr>
-          <p:cNvPr id="18" name="Text 14"/>
-          <p:cNvSpPr/>
-          <p:nvPr/>
-        </p:nvSpPr>
-        <p:spPr>
-          <a:xfrm>
-            <a:off x="960120" y="6254496"/>
+          <p:cNvPr id="22" name="Text 16"/>
+          <p:cNvSpPr/>
+          <p:nvPr/>
+        </p:nvSpPr>
+        <p:spPr>
+          <a:xfrm>
+            <a:off x="960120" y="5522976"/>
             <a:ext cx="2286000" cy="274320"/>
           </a:xfrm>
           <a:prstGeom prst="rect">
@@ -2967,13 +3093,13 @@
       </p:sp>
       <p:sp>
         <p:nvSpPr>
-          <p:cNvPr id="19" name="Shape 15"/>
-          <p:cNvSpPr/>
-          <p:nvPr/>
-        </p:nvSpPr>
-        <p:spPr>
-          <a:xfrm>
-            <a:off x="3429000" y="6300216"/>
+          <p:cNvPr id="23" name="Shape 17"/>
+          <p:cNvSpPr/>
+          <p:nvPr/>
+        </p:nvSpPr>
+        <p:spPr>
+          <a:xfrm>
+            <a:off x="3429000" y="5568696"/>
             <a:ext cx="182880" cy="182880"/>
           </a:xfrm>
           <a:prstGeom prst="rect">
@@ -2987,13 +3113,13 @@
       </p:sp>
       <p:sp>
         <p:nvSpPr>
-          <p:cNvPr id="20" name="Text 16"/>
-          <p:cNvSpPr/>
-          <p:nvPr/>
-        </p:nvSpPr>
-        <p:spPr>
-          <a:xfrm>
-            <a:off x="3703320" y="6254496"/>
+          <p:cNvPr id="24" name="Text 18"/>
+          <p:cNvSpPr/>
+          <p:nvPr/>
+        </p:nvSpPr>
+        <p:spPr>
+          <a:xfrm>
+            <a:off x="3703320" y="5522976"/>
             <a:ext cx="2286000" cy="274320"/>
           </a:xfrm>
           <a:prstGeom prst="rect">
@@ -3026,13 +3152,13 @@
       </p:sp>
       <p:sp>
         <p:nvSpPr>
-          <p:cNvPr id="21" name="Shape 17"/>
-          <p:cNvSpPr/>
-          <p:nvPr/>
-        </p:nvSpPr>
-        <p:spPr>
-          <a:xfrm>
-            <a:off x="6172200" y="6300216"/>
+          <p:cNvPr id="25" name="Shape 19"/>
+          <p:cNvSpPr/>
+          <p:nvPr/>
+        </p:nvSpPr>
+        <p:spPr>
+          <a:xfrm>
+            <a:off x="6172200" y="5568696"/>
             <a:ext cx="182880" cy="182880"/>
           </a:xfrm>
           <a:prstGeom prst="rect">
@@ -3046,13 +3172,13 @@
       </p:sp>
       <p:sp>
         <p:nvSpPr>
-          <p:cNvPr id="22" name="Text 18"/>
-          <p:cNvSpPr/>
-          <p:nvPr/>
-        </p:nvSpPr>
-        <p:spPr>
-          <a:xfrm>
-            <a:off x="6446520" y="6254496"/>
+          <p:cNvPr id="26" name="Text 20"/>
+          <p:cNvSpPr/>
+          <p:nvPr/>
+        </p:nvSpPr>
+        <p:spPr>
+          <a:xfrm>
+            <a:off x="6446520" y="5522976"/>
             <a:ext cx="2286000" cy="274320"/>
           </a:xfrm>
           <a:prstGeom prst="rect">
@@ -3085,13 +3211,13 @@
       </p:sp>
       <p:sp>
         <p:nvSpPr>
-          <p:cNvPr id="23" name="Shape 19"/>
-          <p:cNvSpPr/>
-          <p:nvPr/>
-        </p:nvSpPr>
-        <p:spPr>
-          <a:xfrm>
-            <a:off x="8915400" y="6300216"/>
+          <p:cNvPr id="27" name="Shape 21"/>
+          <p:cNvSpPr/>
+          <p:nvPr/>
+        </p:nvSpPr>
+        <p:spPr>
+          <a:xfrm>
+            <a:off x="8915400" y="5568696"/>
             <a:ext cx="182880" cy="182880"/>
           </a:xfrm>
           <a:prstGeom prst="rect">
@@ -3105,13 +3231,13 @@
       </p:sp>
       <p:sp>
         <p:nvSpPr>
-          <p:cNvPr id="24" name="Text 20"/>
-          <p:cNvSpPr/>
-          <p:nvPr/>
-        </p:nvSpPr>
-        <p:spPr>
-          <a:xfrm>
-            <a:off x="9189720" y="6254496"/>
+          <p:cNvPr id="28" name="Text 22"/>
+          <p:cNvSpPr/>
+          <p:nvPr/>
+        </p:nvSpPr>
+        <p:spPr>
+          <a:xfrm>
+            <a:off x="9189720" y="5522976"/>
             <a:ext cx="2286000" cy="274320"/>
           </a:xfrm>
           <a:prstGeom prst="rect">
@@ -3144,13 +3270,13 @@
       </p:sp>
       <p:sp>
         <p:nvSpPr>
-          <p:cNvPr id="25" name="Shape 21"/>
-          <p:cNvSpPr/>
-          <p:nvPr/>
-        </p:nvSpPr>
-        <p:spPr>
-          <a:xfrm>
-            <a:off x="685800" y="6592824"/>
+          <p:cNvPr id="29" name="Shape 23"/>
+          <p:cNvSpPr/>
+          <p:nvPr/>
+        </p:nvSpPr>
+        <p:spPr>
+          <a:xfrm>
+            <a:off x="685800" y="5861304"/>
             <a:ext cx="182880" cy="182880"/>
           </a:xfrm>
           <a:prstGeom prst="rect">
@@ -3164,13 +3290,13 @@
       </p:sp>
       <p:sp>
         <p:nvSpPr>
-          <p:cNvPr id="26" name="Text 22"/>
-          <p:cNvSpPr/>
-          <p:nvPr/>
-        </p:nvSpPr>
-        <p:spPr>
-          <a:xfrm>
-            <a:off x="960120" y="6547104"/>
+          <p:cNvPr id="30" name="Text 24"/>
+          <p:cNvSpPr/>
+          <p:nvPr/>
+        </p:nvSpPr>
+        <p:spPr>
+          <a:xfrm>
+            <a:off x="960120" y="5815584"/>
             <a:ext cx="2286000" cy="274320"/>
           </a:xfrm>
           <a:prstGeom prst="rect">
@@ -3203,13 +3329,13 @@
       </p:sp>
       <p:sp>
         <p:nvSpPr>
-          <p:cNvPr id="27" name="Shape 23"/>
-          <p:cNvSpPr/>
-          <p:nvPr/>
-        </p:nvSpPr>
-        <p:spPr>
-          <a:xfrm>
-            <a:off x="3429000" y="6592824"/>
+          <p:cNvPr id="31" name="Shape 25"/>
+          <p:cNvSpPr/>
+          <p:nvPr/>
+        </p:nvSpPr>
+        <p:spPr>
+          <a:xfrm>
+            <a:off x="3429000" y="5861304"/>
             <a:ext cx="182880" cy="182880"/>
           </a:xfrm>
           <a:prstGeom prst="rect">
@@ -3223,13 +3349,13 @@
       </p:sp>
       <p:sp>
         <p:nvSpPr>
-          <p:cNvPr id="28" name="Text 24"/>
-          <p:cNvSpPr/>
-          <p:nvPr/>
-        </p:nvSpPr>
-        <p:spPr>
-          <a:xfrm>
-            <a:off x="3703320" y="6547104"/>
+          <p:cNvPr id="32" name="Text 26"/>
+          <p:cNvSpPr/>
+          <p:nvPr/>
+        </p:nvSpPr>
+        <p:spPr>
+          <a:xfrm>
+            <a:off x="3703320" y="5815584"/>
             <a:ext cx="2286000" cy="274320"/>
           </a:xfrm>
           <a:prstGeom prst="rect">
@@ -3262,13 +3388,13 @@
       </p:sp>
       <p:sp>
         <p:nvSpPr>
-          <p:cNvPr id="29" name="Shape 25"/>
-          <p:cNvSpPr/>
-          <p:nvPr/>
-        </p:nvSpPr>
-        <p:spPr>
-          <a:xfrm>
-            <a:off x="6172200" y="6592824"/>
+          <p:cNvPr id="33" name="Shape 27"/>
+          <p:cNvSpPr/>
+          <p:nvPr/>
+        </p:nvSpPr>
+        <p:spPr>
+          <a:xfrm>
+            <a:off x="6172200" y="5861304"/>
             <a:ext cx="182880" cy="182880"/>
           </a:xfrm>
           <a:prstGeom prst="rect">
@@ -3282,13 +3408,13 @@
       </p:sp>
       <p:sp>
         <p:nvSpPr>
-          <p:cNvPr id="30" name="Text 26"/>
-          <p:cNvSpPr/>
-          <p:nvPr/>
-        </p:nvSpPr>
-        <p:spPr>
-          <a:xfrm>
-            <a:off x="6446520" y="6547104"/>
+          <p:cNvPr id="34" name="Text 28"/>
+          <p:cNvSpPr/>
+          <p:nvPr/>
+        </p:nvSpPr>
+        <p:spPr>
+          <a:xfrm>
+            <a:off x="6446520" y="5815584"/>
             <a:ext cx="2286000" cy="274320"/>
           </a:xfrm>
           <a:prstGeom prst="rect">
@@ -3321,13 +3447,13 @@
       </p:sp>
       <p:sp>
         <p:nvSpPr>
-          <p:cNvPr id="31" name="Shape 27"/>
-          <p:cNvSpPr/>
-          <p:nvPr/>
-        </p:nvSpPr>
-        <p:spPr>
-          <a:xfrm>
-            <a:off x="8915400" y="6592824"/>
+          <p:cNvPr id="35" name="Shape 29"/>
+          <p:cNvSpPr/>
+          <p:nvPr/>
+        </p:nvSpPr>
+        <p:spPr>
+          <a:xfrm>
+            <a:off x="8915400" y="5861304"/>
             <a:ext cx="182880" cy="182880"/>
           </a:xfrm>
           <a:prstGeom prst="rect">
@@ -3341,13 +3467,13 @@
       </p:sp>
       <p:sp>
         <p:nvSpPr>
-          <p:cNvPr id="32" name="Text 28"/>
-          <p:cNvSpPr/>
-          <p:nvPr/>
-        </p:nvSpPr>
-        <p:spPr>
-          <a:xfrm>
-            <a:off x="9189720" y="6547104"/>
+          <p:cNvPr id="36" name="Text 30"/>
+          <p:cNvSpPr/>
+          <p:nvPr/>
+        </p:nvSpPr>
+        <p:spPr>
+          <a:xfrm>
+            <a:off x="9189720" y="5815584"/>
             <a:ext cx="2286000" cy="274320"/>
           </a:xfrm>
           <a:prstGeom prst="rect">

</xml_diff>